<commit_message>
Correção do slide LP
</commit_message>
<xml_diff>
--- a/UNIUBE-LP/Slides/06 - Modulos e Erros.pptx
+++ b/UNIUBE-LP/Slides/06 - Modulos e Erros.pptx
@@ -214,7 +214,7 @@
           <a:p>
             <a:fld id="{6ED03497-8374-466E-85FA-95E1138D8F6E}" type="datetimeFigureOut">
               <a:rPr lang="pt-BR" smtClean="0"/>
-              <a:t>07/09/2026</a:t>
+              <a:t>08/09/2026</a:t>
             </a:fld>
             <a:endParaRPr lang="pt-BR"/>
           </a:p>
@@ -2763,6 +2763,12 @@
               <a:rPr lang="pt-BR" dirty="0"/>
               <a:t> que adota um comportamento de acordo com fluxos condicionais esperados.</a:t>
             </a:r>
+          </a:p>
+          <a:p>
+            <a:pPr marL="171450" indent="-171450">
+              <a:buFont typeface="Arial" panose="020B0604020202020204" pitchFamily="34" charset="0"/>
+              <a:buChar char="•"/>
+            </a:pPr>
             <a:endParaRPr lang="pt-BR" sz="1200" b="0" kern="1200" dirty="0">
               <a:solidFill>
                 <a:schemeClr val="tx1"/>
@@ -2772,6 +2778,135 @@
               <a:ea typeface="+mn-ea"/>
               <a:cs typeface="+mn-cs"/>
             </a:endParaRPr>
+          </a:p>
+          <a:p>
+            <a:pPr marL="628650" lvl="1" indent="-171450">
+              <a:buFont typeface="Arial" panose="020B0604020202020204" pitchFamily="34" charset="0"/>
+              <a:buChar char="•"/>
+            </a:pPr>
+            <a:r>
+              <a:rPr lang="pt-BR" sz="1200" b="0" kern="1200" dirty="0" err="1">
+                <a:solidFill>
+                  <a:schemeClr val="tx1"/>
+                </a:solidFill>
+                <a:effectLst/>
+                <a:latin typeface="+mn-lt"/>
+                <a:ea typeface="+mn-ea"/>
+                <a:cs typeface="+mn-cs"/>
+              </a:rPr>
+              <a:t>Try</a:t>
+            </a:r>
+            <a:r>
+              <a:rPr lang="pt-BR" sz="1200" b="0" kern="1200" dirty="0">
+                <a:solidFill>
+                  <a:schemeClr val="tx1"/>
+                </a:solidFill>
+                <a:effectLst/>
+                <a:latin typeface="+mn-lt"/>
+                <a:ea typeface="+mn-ea"/>
+                <a:cs typeface="+mn-cs"/>
+              </a:rPr>
+              <a:t> – Executa um código que pode gerar algum erro</a:t>
+            </a:r>
+          </a:p>
+          <a:p>
+            <a:pPr marL="628650" lvl="1" indent="-171450">
+              <a:buFont typeface="Arial" panose="020B0604020202020204" pitchFamily="34" charset="0"/>
+              <a:buChar char="•"/>
+            </a:pPr>
+            <a:r>
+              <a:rPr lang="pt-BR" sz="1200" b="0" kern="1200" dirty="0" err="1">
+                <a:solidFill>
+                  <a:schemeClr val="tx1"/>
+                </a:solidFill>
+                <a:effectLst/>
+                <a:latin typeface="+mn-lt"/>
+                <a:ea typeface="+mn-ea"/>
+                <a:cs typeface="+mn-cs"/>
+              </a:rPr>
+              <a:t>Throw</a:t>
+            </a:r>
+            <a:r>
+              <a:rPr lang="pt-BR" sz="1200" b="0" kern="1200" dirty="0">
+                <a:solidFill>
+                  <a:schemeClr val="tx1"/>
+                </a:solidFill>
+                <a:effectLst/>
+                <a:latin typeface="+mn-lt"/>
+                <a:ea typeface="+mn-ea"/>
+                <a:cs typeface="+mn-cs"/>
+              </a:rPr>
+              <a:t> – Define um erro customizado ao detectar um erro</a:t>
+            </a:r>
+          </a:p>
+          <a:p>
+            <a:pPr marL="628650" lvl="1" indent="-171450">
+              <a:buFont typeface="Arial" panose="020B0604020202020204" pitchFamily="34" charset="0"/>
+              <a:buChar char="•"/>
+            </a:pPr>
+            <a:r>
+              <a:rPr lang="pt-BR" sz="1200" b="0" kern="1200" dirty="0">
+                <a:solidFill>
+                  <a:schemeClr val="tx1"/>
+                </a:solidFill>
+                <a:effectLst/>
+                <a:latin typeface="+mn-lt"/>
+                <a:ea typeface="+mn-ea"/>
+                <a:cs typeface="+mn-cs"/>
+              </a:rPr>
+              <a:t>Catch – Executa quando um erro é detectado em </a:t>
+            </a:r>
+            <a:r>
+              <a:rPr lang="pt-BR" sz="1200" b="0" kern="1200" dirty="0" err="1">
+                <a:solidFill>
+                  <a:schemeClr val="tx1"/>
+                </a:solidFill>
+                <a:effectLst/>
+                <a:latin typeface="+mn-lt"/>
+                <a:ea typeface="+mn-ea"/>
+                <a:cs typeface="+mn-cs"/>
+              </a:rPr>
+              <a:t>Try</a:t>
+            </a:r>
+            <a:endParaRPr lang="pt-BR" sz="1200" b="0" kern="1200" dirty="0">
+              <a:solidFill>
+                <a:schemeClr val="tx1"/>
+              </a:solidFill>
+              <a:effectLst/>
+              <a:latin typeface="+mn-lt"/>
+              <a:ea typeface="+mn-ea"/>
+              <a:cs typeface="+mn-cs"/>
+            </a:endParaRPr>
+          </a:p>
+          <a:p>
+            <a:pPr marL="628650" lvl="1" indent="-171450">
+              <a:buFont typeface="Arial" panose="020B0604020202020204" pitchFamily="34" charset="0"/>
+              <a:buChar char="•"/>
+            </a:pPr>
+            <a:r>
+              <a:rPr lang="pt-BR" sz="1200" b="0" kern="1200" dirty="0" err="1">
+                <a:solidFill>
+                  <a:schemeClr val="tx1"/>
+                </a:solidFill>
+                <a:effectLst/>
+                <a:latin typeface="+mn-lt"/>
+                <a:ea typeface="+mn-ea"/>
+                <a:cs typeface="+mn-cs"/>
+              </a:rPr>
+              <a:t>Finally</a:t>
+            </a:r>
+            <a:r>
+              <a:rPr lang="pt-BR" sz="1200" b="0" kern="1200" dirty="0">
+                <a:solidFill>
+                  <a:schemeClr val="tx1"/>
+                </a:solidFill>
+                <a:effectLst/>
+                <a:latin typeface="+mn-lt"/>
+                <a:ea typeface="+mn-ea"/>
+                <a:cs typeface="+mn-cs"/>
+              </a:rPr>
+              <a:t> – Executa independente da ocorrência de um erro (Geralmente funções relacionadas à limpeza de memória).</a:t>
+            </a:r>
           </a:p>
         </p:txBody>
       </p:sp>
@@ -2964,7 +3099,7 @@
           <a:p>
             <a:fld id="{A87E3B6E-8316-4A1C-BADA-DB7F3456EEF1}" type="datetimeFigureOut">
               <a:rPr lang="pt-BR" smtClean="0"/>
-              <a:t>07/09/2026</a:t>
+              <a:t>08/09/2026</a:t>
             </a:fld>
             <a:endParaRPr lang="pt-BR"/>
           </a:p>
@@ -3162,7 +3297,7 @@
           <a:p>
             <a:fld id="{A87E3B6E-8316-4A1C-BADA-DB7F3456EEF1}" type="datetimeFigureOut">
               <a:rPr lang="pt-BR" smtClean="0"/>
-              <a:t>07/09/2026</a:t>
+              <a:t>08/09/2026</a:t>
             </a:fld>
             <a:endParaRPr lang="pt-BR"/>
           </a:p>
@@ -3370,7 +3505,7 @@
           <a:p>
             <a:fld id="{A87E3B6E-8316-4A1C-BADA-DB7F3456EEF1}" type="datetimeFigureOut">
               <a:rPr lang="pt-BR" smtClean="0"/>
-              <a:t>07/09/2026</a:t>
+              <a:t>08/09/2026</a:t>
             </a:fld>
             <a:endParaRPr lang="pt-BR"/>
           </a:p>
@@ -3606,7 +3741,7 @@
           <a:p>
             <a:fld id="{A87E3B6E-8316-4A1C-BADA-DB7F3456EEF1}" type="datetimeFigureOut">
               <a:rPr lang="pt-BR" smtClean="0"/>
-              <a:t>07/09/2026</a:t>
+              <a:t>08/09/2026</a:t>
             </a:fld>
             <a:endParaRPr lang="pt-BR"/>
           </a:p>
@@ -3776,7 +3911,7 @@
           <a:p>
             <a:fld id="{A87E3B6E-8316-4A1C-BADA-DB7F3456EEF1}" type="datetimeFigureOut">
               <a:rPr lang="pt-BR" smtClean="0"/>
-              <a:t>07/09/2026</a:t>
+              <a:t>08/09/2026</a:t>
             </a:fld>
             <a:endParaRPr lang="pt-BR"/>
           </a:p>
@@ -4044,7 +4179,7 @@
           <a:p>
             <a:fld id="{A87E3B6E-8316-4A1C-BADA-DB7F3456EEF1}" type="datetimeFigureOut">
               <a:rPr lang="pt-BR" smtClean="0"/>
-              <a:t>07/09/2026</a:t>
+              <a:t>08/09/2026</a:t>
             </a:fld>
             <a:endParaRPr lang="pt-BR"/>
           </a:p>
@@ -4276,7 +4411,7 @@
           <a:p>
             <a:fld id="{A87E3B6E-8316-4A1C-BADA-DB7F3456EEF1}" type="datetimeFigureOut">
               <a:rPr lang="pt-BR" smtClean="0"/>
-              <a:t>07/09/2026</a:t>
+              <a:t>08/09/2026</a:t>
             </a:fld>
             <a:endParaRPr lang="pt-BR"/>
           </a:p>
@@ -4631,7 +4766,7 @@
           <a:p>
             <a:fld id="{A87E3B6E-8316-4A1C-BADA-DB7F3456EEF1}" type="datetimeFigureOut">
               <a:rPr lang="pt-BR" smtClean="0"/>
-              <a:t>07/09/2026</a:t>
+              <a:t>08/09/2026</a:t>
             </a:fld>
             <a:endParaRPr lang="pt-BR"/>
           </a:p>
@@ -4772,7 +4907,7 @@
           <a:p>
             <a:fld id="{A87E3B6E-8316-4A1C-BADA-DB7F3456EEF1}" type="datetimeFigureOut">
               <a:rPr lang="pt-BR" smtClean="0"/>
-              <a:t>07/09/2026</a:t>
+              <a:t>08/09/2026</a:t>
             </a:fld>
             <a:endParaRPr lang="pt-BR"/>
           </a:p>
@@ -4867,7 +5002,7 @@
           <a:p>
             <a:fld id="{A87E3B6E-8316-4A1C-BADA-DB7F3456EEF1}" type="datetimeFigureOut">
               <a:rPr lang="pt-BR" smtClean="0"/>
-              <a:t>07/09/2026</a:t>
+              <a:t>08/09/2026</a:t>
             </a:fld>
             <a:endParaRPr lang="pt-BR"/>
           </a:p>
@@ -5224,7 +5359,7 @@
           <a:p>
             <a:fld id="{A87E3B6E-8316-4A1C-BADA-DB7F3456EEF1}" type="datetimeFigureOut">
               <a:rPr lang="pt-BR" smtClean="0"/>
-              <a:t>07/09/2026</a:t>
+              <a:t>08/09/2026</a:t>
             </a:fld>
             <a:endParaRPr lang="pt-BR"/>
           </a:p>
@@ -5425,7 +5560,7 @@
           <a:p>
             <a:fld id="{A87E3B6E-8316-4A1C-BADA-DB7F3456EEF1}" type="datetimeFigureOut">
               <a:rPr lang="pt-BR" smtClean="0"/>
-              <a:t>07/09/2026</a:t>
+              <a:t>08/09/2026</a:t>
             </a:fld>
             <a:endParaRPr lang="pt-BR"/>
           </a:p>
@@ -5778,7 +5913,7 @@
           <a:p>
             <a:fld id="{A87E3B6E-8316-4A1C-BADA-DB7F3456EEF1}" type="datetimeFigureOut">
               <a:rPr lang="pt-BR" smtClean="0"/>
-              <a:t>07/09/2026</a:t>
+              <a:t>08/09/2026</a:t>
             </a:fld>
             <a:endParaRPr lang="pt-BR"/>
           </a:p>
@@ -5963,7 +6098,7 @@
           <a:p>
             <a:fld id="{A87E3B6E-8316-4A1C-BADA-DB7F3456EEF1}" type="datetimeFigureOut">
               <a:rPr lang="pt-BR" smtClean="0"/>
-              <a:t>07/09/2026</a:t>
+              <a:t>08/09/2026</a:t>
             </a:fld>
             <a:endParaRPr lang="pt-BR"/>
           </a:p>
@@ -6143,7 +6278,7 @@
           <a:p>
             <a:fld id="{A87E3B6E-8316-4A1C-BADA-DB7F3456EEF1}" type="datetimeFigureOut">
               <a:rPr lang="pt-BR" smtClean="0"/>
-              <a:t>07/09/2026</a:t>
+              <a:t>08/09/2026</a:t>
             </a:fld>
             <a:endParaRPr lang="pt-BR"/>
           </a:p>
@@ -6406,7 +6541,7 @@
           <a:p>
             <a:fld id="{A87E3B6E-8316-4A1C-BADA-DB7F3456EEF1}" type="datetimeFigureOut">
               <a:rPr lang="pt-BR" smtClean="0"/>
-              <a:t>07/09/2026</a:t>
+              <a:t>08/09/2026</a:t>
             </a:fld>
             <a:endParaRPr lang="pt-BR"/>
           </a:p>
@@ -6671,7 +6806,7 @@
           <a:p>
             <a:fld id="{A87E3B6E-8316-4A1C-BADA-DB7F3456EEF1}" type="datetimeFigureOut">
               <a:rPr lang="pt-BR" smtClean="0"/>
-              <a:t>07/09/2026</a:t>
+              <a:t>08/09/2026</a:t>
             </a:fld>
             <a:endParaRPr lang="pt-BR"/>
           </a:p>
@@ -7083,7 +7218,7 @@
           <a:p>
             <a:fld id="{A87E3B6E-8316-4A1C-BADA-DB7F3456EEF1}" type="datetimeFigureOut">
               <a:rPr lang="pt-BR" smtClean="0"/>
-              <a:t>07/09/2026</a:t>
+              <a:t>08/09/2026</a:t>
             </a:fld>
             <a:endParaRPr lang="pt-BR"/>
           </a:p>
@@ -7224,7 +7359,7 @@
           <a:p>
             <a:fld id="{A87E3B6E-8316-4A1C-BADA-DB7F3456EEF1}" type="datetimeFigureOut">
               <a:rPr lang="pt-BR" smtClean="0"/>
-              <a:t>07/09/2026</a:t>
+              <a:t>08/09/2026</a:t>
             </a:fld>
             <a:endParaRPr lang="pt-BR"/>
           </a:p>
@@ -7337,7 +7472,7 @@
           <a:p>
             <a:fld id="{A87E3B6E-8316-4A1C-BADA-DB7F3456EEF1}" type="datetimeFigureOut">
               <a:rPr lang="pt-BR" smtClean="0"/>
-              <a:t>07/09/2026</a:t>
+              <a:t>08/09/2026</a:t>
             </a:fld>
             <a:endParaRPr lang="pt-BR"/>
           </a:p>
@@ -7648,7 +7783,7 @@
           <a:p>
             <a:fld id="{A87E3B6E-8316-4A1C-BADA-DB7F3456EEF1}" type="datetimeFigureOut">
               <a:rPr lang="pt-BR" smtClean="0"/>
-              <a:t>07/09/2026</a:t>
+              <a:t>08/09/2026</a:t>
             </a:fld>
             <a:endParaRPr lang="pt-BR"/>
           </a:p>
@@ -7936,7 +8071,7 @@
           <a:p>
             <a:fld id="{A87E3B6E-8316-4A1C-BADA-DB7F3456EEF1}" type="datetimeFigureOut">
               <a:rPr lang="pt-BR" smtClean="0"/>
-              <a:t>07/09/2026</a:t>
+              <a:t>08/09/2026</a:t>
             </a:fld>
             <a:endParaRPr lang="pt-BR"/>
           </a:p>
@@ -8177,7 +8312,7 @@
           <a:p>
             <a:fld id="{A87E3B6E-8316-4A1C-BADA-DB7F3456EEF1}" type="datetimeFigureOut">
               <a:rPr lang="pt-BR" smtClean="0"/>
-              <a:t>07/09/2026</a:t>
+              <a:t>08/09/2026</a:t>
             </a:fld>
             <a:endParaRPr lang="pt-BR"/>
           </a:p>
@@ -8741,7 +8876,7 @@
           <a:p>
             <a:fld id="{A87E3B6E-8316-4A1C-BADA-DB7F3456EEF1}" type="datetimeFigureOut">
               <a:rPr lang="pt-BR" smtClean="0"/>
-              <a:t>07/09/2026</a:t>
+              <a:t>08/09/2026</a:t>
             </a:fld>
             <a:endParaRPr lang="pt-BR"/>
           </a:p>
@@ -15887,10 +16022,10 @@
       </p:sp>
       <p:pic>
         <p:nvPicPr>
-          <p:cNvPr id="20" name="Imagem 19">
-            <a:extLst>
-              <a:ext uri="{FF2B5EF4-FFF2-40B4-BE49-F238E27FC236}">
-                <a16:creationId xmlns:a16="http://schemas.microsoft.com/office/drawing/2014/main" id="{B1A2C8D1-FCD0-98AD-6854-1435F5153905}"/>
+          <p:cNvPr id="6" name="Imagem 5">
+            <a:extLst>
+              <a:ext uri="{FF2B5EF4-FFF2-40B4-BE49-F238E27FC236}">
+                <a16:creationId xmlns:a16="http://schemas.microsoft.com/office/drawing/2014/main" id="{0378B348-F7E4-0A15-5D98-784E285C6DD6}"/>
               </a:ext>
             </a:extLst>
           </p:cNvPr>
@@ -15907,8 +16042,8 @@
         </p:blipFill>
         <p:spPr>
           <a:xfrm>
-            <a:off x="4520031" y="4254163"/>
-            <a:ext cx="3179679" cy="1614174"/>
+            <a:off x="4673483" y="4118142"/>
+            <a:ext cx="2915057" cy="1886213"/>
           </a:xfrm>
           <a:prstGeom prst="rect">
             <a:avLst/>
@@ -16804,8 +16939,8 @@
         </p:nvSpPr>
         <p:spPr>
           <a:xfrm>
-            <a:off x="7675042" y="4742917"/>
-            <a:ext cx="4148658" cy="1574800"/>
+            <a:off x="7838740" y="4742915"/>
+            <a:ext cx="3821259" cy="1574800"/>
           </a:xfrm>
           <a:prstGeom prst="rect">
             <a:avLst/>
@@ -16853,10 +16988,10 @@
       </p:sp>
       <p:pic>
         <p:nvPicPr>
-          <p:cNvPr id="7" name="Imagem 6">
-            <a:extLst>
-              <a:ext uri="{FF2B5EF4-FFF2-40B4-BE49-F238E27FC236}">
-                <a16:creationId xmlns:a16="http://schemas.microsoft.com/office/drawing/2014/main" id="{34ADD0CB-6F9A-7F22-064C-AE2B729DD7A5}"/>
+          <p:cNvPr id="8" name="Imagem 7">
+            <a:extLst>
+              <a:ext uri="{FF2B5EF4-FFF2-40B4-BE49-F238E27FC236}">
+                <a16:creationId xmlns:a16="http://schemas.microsoft.com/office/drawing/2014/main" id="{402929DF-E1DC-1B4F-401F-11ED793C9716}"/>
               </a:ext>
             </a:extLst>
           </p:cNvPr>
@@ -16873,8 +17008,8 @@
         </p:blipFill>
         <p:spPr>
           <a:xfrm>
-            <a:off x="7675042" y="1981200"/>
-            <a:ext cx="4148658" cy="2106079"/>
+            <a:off x="7838741" y="1797949"/>
+            <a:ext cx="3821259" cy="2472579"/>
           </a:xfrm>
           <a:prstGeom prst="rect">
             <a:avLst/>
@@ -17222,36 +17357,6 @@
           </a:p>
         </p:txBody>
       </p:sp>
-      <p:pic>
-        <p:nvPicPr>
-          <p:cNvPr id="14" name="Imagem 13">
-            <a:extLst>
-              <a:ext uri="{FF2B5EF4-FFF2-40B4-BE49-F238E27FC236}">
-                <a16:creationId xmlns:a16="http://schemas.microsoft.com/office/drawing/2014/main" id="{B615F2B6-2565-13A4-4EBE-F7BED23B001B}"/>
-              </a:ext>
-            </a:extLst>
-          </p:cNvPr>
-          <p:cNvPicPr>
-            <a:picLocks noChangeAspect="1"/>
-          </p:cNvPicPr>
-          <p:nvPr/>
-        </p:nvPicPr>
-        <p:blipFill>
-          <a:blip r:embed="rId5"/>
-          <a:stretch>
-            <a:fillRect/>
-          </a:stretch>
-        </p:blipFill>
-        <p:spPr>
-          <a:xfrm>
-            <a:off x="4520031" y="2196763"/>
-            <a:ext cx="3179679" cy="1614174"/>
-          </a:xfrm>
-          <a:prstGeom prst="rect">
-            <a:avLst/>
-          </a:prstGeom>
-        </p:spPr>
-      </p:pic>
       <p:sp>
         <p:nvSpPr>
           <p:cNvPr id="16" name="Espaço Reservado para Conteúdo 5">
@@ -17546,6 +17651,36 @@
           </a:p>
         </p:txBody>
       </p:sp>
+      <p:pic>
+        <p:nvPicPr>
+          <p:cNvPr id="4" name="Imagem 3">
+            <a:extLst>
+              <a:ext uri="{FF2B5EF4-FFF2-40B4-BE49-F238E27FC236}">
+                <a16:creationId xmlns:a16="http://schemas.microsoft.com/office/drawing/2014/main" id="{9B88F953-13B8-F662-9162-CEDF0B78021E}"/>
+              </a:ext>
+            </a:extLst>
+          </p:cNvPr>
+          <p:cNvPicPr>
+            <a:picLocks noChangeAspect="1"/>
+          </p:cNvPicPr>
+          <p:nvPr/>
+        </p:nvPicPr>
+        <p:blipFill>
+          <a:blip r:embed="rId5"/>
+          <a:stretch>
+            <a:fillRect/>
+          </a:stretch>
+        </p:blipFill>
+        <p:spPr>
+          <a:xfrm>
+            <a:off x="4685558" y="2067082"/>
+            <a:ext cx="2915057" cy="1886213"/>
+          </a:xfrm>
+          <a:prstGeom prst="rect">
+            <a:avLst/>
+          </a:prstGeom>
+        </p:spPr>
+      </p:pic>
     </p:spTree>
     <p:extLst>
       <p:ext uri="{BB962C8B-B14F-4D97-AF65-F5344CB8AC3E}">

</xml_diff>